<commit_message>
Saving the Tokens: replace closing slide with two takeaway slides
</commit_message>
<xml_diff>
--- a/Saving-the-Tokens/slides/Saving_the_Tokens.pptx
+++ b/Saving-the-Tokens/slides/Saving_the_Tokens.pptx
@@ -24,6 +24,7 @@
     <p:sldId id="272" r:id="rId23"/>
     <p:sldId id="273" r:id="rId24"/>
     <p:sldId id="274" r:id="rId25"/>
+    <p:sldId id="275" r:id="rId26"/>
   </p:sldIdLst>
   <p:sldSz cx="12191695" cy="6858000" type="screen4x3"/>
   <p:notesSz cx="6858000" cy="9144000"/>
@@ -9689,7 +9690,7 @@
                 </a:solidFill>
                 <a:latin typeface="Aptos Display"/>
               </a:rPr>
-              <a:t>Monday morning: find YOUR big number</a:t>
+              <a:t>Four things that are easy to get wrong</a:t>
             </a:r>
           </a:p>
         </p:txBody>
@@ -9703,7 +9704,7 @@
         <p:spPr>
           <a:xfrm>
             <a:off x="685800" y="1737360"/>
-            <a:ext cx="2514600" cy="1874519"/>
+            <a:ext cx="5272887" cy="2103120"/>
           </a:xfrm>
           <a:prstGeom prst="roundRect">
             <a:avLst>
@@ -9748,8 +9749,8 @@
         </p:nvSpPr>
         <p:spPr>
           <a:xfrm>
-            <a:off x="960120" y="1901952"/>
-            <a:ext cx="914400" cy="640080"/>
+            <a:off x="960120" y="1920240"/>
+            <a:ext cx="4724247" cy="731520"/>
           </a:xfrm>
           <a:prstGeom prst="rect">
             <a:avLst/>
@@ -9771,13 +9772,13 @@
               </a:spcAft>
             </a:pPr>
             <a:r>
-              <a:rPr sz="4000" b="1">
-                <a:solidFill>
-                  <a:srgbClr val="5AA3F0"/>
+              <a:rPr sz="3800" b="1">
+                <a:solidFill>
+                  <a:srgbClr val="F0834E"/>
                 </a:solidFill>
                 <a:latin typeface="Aptos Display"/>
               </a:rPr>
-              <a:t>1</a:t>
+              <a:t>2.0×</a:t>
             </a:r>
           </a:p>
         </p:txBody>
@@ -9790,8 +9791,8 @@
         </p:nvSpPr>
         <p:spPr>
           <a:xfrm>
-            <a:off x="960120" y="2651760"/>
-            <a:ext cx="2057400" cy="914400"/>
+            <a:off x="960120" y="2606040"/>
+            <a:ext cx="4724247" cy="365760"/>
           </a:xfrm>
           <a:prstGeom prst="rect">
             <a:avLst/>
@@ -9813,27 +9814,69 @@
               </a:spcAft>
             </a:pPr>
             <a:r>
-              <a:rPr sz="1700" b="0">
+              <a:rPr sz="1900" b="1">
+                <a:solidFill>
+                  <a:srgbClr val="FFFFFF"/>
+                </a:solidFill>
+                <a:latin typeface="Aptos"/>
+              </a:rPr>
+              <a:t>Caching + pruning is worse than caching</a:t>
+            </a:r>
+          </a:p>
+        </p:txBody>
+      </p:sp>
+      <p:sp>
+        <p:nvSpPr>
+          <p:cNvPr id="11" name="TextBox 10"/>
+          <p:cNvSpPr txBox="1"/>
+          <p:nvPr/>
+        </p:nvSpPr>
+        <p:spPr>
+          <a:xfrm>
+            <a:off x="960120" y="2999232"/>
+            <a:ext cx="4724247" cy="777240"/>
+          </a:xfrm>
+          <a:prstGeom prst="rect">
+            <a:avLst/>
+          </a:prstGeom>
+          <a:noFill/>
+        </p:spPr>
+        <p:txBody>
+          <a:bodyPr wrap="square" lIns="0" rIns="0" tIns="0" bIns="0" anchor="t">
+            <a:spAutoFit/>
+          </a:bodyPr>
+          <a:lstStyle/>
+          <a:p>
+            <a:pPr algn="l">
+              <a:lnSpc>
+                <a:spcPct val="112000"/>
+              </a:lnSpc>
+              <a:spcAft>
+                <a:spcPts val="0"/>
+              </a:spcAft>
+            </a:pPr>
+            <a:r>
+              <a:rPr sz="1400" b="0">
                 <a:solidFill>
                   <a:srgbClr val="D7D5CE"/>
                 </a:solidFill>
                 <a:latin typeface="Aptos"/>
               </a:rPr>
-              <a:t>Log input tokens on every model call.</a:t>
-            </a:r>
-          </a:p>
-        </p:txBody>
-      </p:sp>
-      <p:sp>
-        <p:nvSpPr>
-          <p:cNvPr id="11" name="Rounded Rectangle 10"/>
+              <a:t>128,630 vs 63,133 tokens. Sliding the window every turn changes the start of the prompt, so the cache misses. Prune in batches.</a:t>
+            </a:r>
+          </a:p>
+        </p:txBody>
+      </p:sp>
+      <p:sp>
+        <p:nvSpPr>
+          <p:cNvPr id="12" name="Rounded Rectangle 11"/>
           <p:cNvSpPr/>
           <p:nvPr/>
         </p:nvSpPr>
         <p:spPr>
           <a:xfrm>
-            <a:off x="3410712" y="1737360"/>
-            <a:ext cx="2514600" cy="1874519"/>
+            <a:off x="6233007" y="1737360"/>
+            <a:ext cx="5272887" cy="2103120"/>
           </a:xfrm>
           <a:prstGeom prst="roundRect">
             <a:avLst>
@@ -9872,14 +9915,14 @@
       </p:sp>
       <p:sp>
         <p:nvSpPr>
-          <p:cNvPr id="12" name="TextBox 11"/>
+          <p:cNvPr id="13" name="TextBox 12"/>
           <p:cNvSpPr txBox="1"/>
           <p:nvPr/>
         </p:nvSpPr>
         <p:spPr>
           <a:xfrm>
-            <a:off x="3685032" y="1901952"/>
-            <a:ext cx="914400" cy="640080"/>
+            <a:off x="6507327" y="1920240"/>
+            <a:ext cx="4724247" cy="731520"/>
           </a:xfrm>
           <a:prstGeom prst="rect">
             <a:avLst/>
@@ -9901,27 +9944,27 @@
               </a:spcAft>
             </a:pPr>
             <a:r>
-              <a:rPr sz="4000" b="1">
+              <a:rPr sz="3800" b="1">
                 <a:solidFill>
                   <a:srgbClr val="5AA3F0"/>
                 </a:solidFill>
                 <a:latin typeface="Aptos Display"/>
               </a:rPr>
-              <a:t>2</a:t>
-            </a:r>
-          </a:p>
-        </p:txBody>
-      </p:sp>
-      <p:sp>
-        <p:nvSpPr>
-          <p:cNvPr id="13" name="TextBox 12"/>
+              <a:t>turn 80</a:t>
+            </a:r>
+          </a:p>
+        </p:txBody>
+      </p:sp>
+      <p:sp>
+        <p:nvSpPr>
+          <p:cNvPr id="14" name="TextBox 13"/>
           <p:cNvSpPr txBox="1"/>
           <p:nvPr/>
         </p:nvSpPr>
         <p:spPr>
           <a:xfrm>
-            <a:off x="3685032" y="2651760"/>
-            <a:ext cx="2057400" cy="914400"/>
+            <a:off x="6507327" y="2606040"/>
+            <a:ext cx="4724247" cy="365760"/>
           </a:xfrm>
           <a:prstGeom prst="rect">
             <a:avLst/>
@@ -9943,27 +9986,69 @@
               </a:spcAft>
             </a:pPr>
             <a:r>
-              <a:rPr sz="1700" b="0">
+              <a:rPr sz="1900" b="1">
+                <a:solidFill>
+                  <a:srgbClr val="FFFFFF"/>
+                </a:solidFill>
+                <a:latin typeface="Aptos"/>
+              </a:rPr>
+              <a:t>Caching buys money, not room</a:t>
+            </a:r>
+          </a:p>
+        </p:txBody>
+      </p:sp>
+      <p:sp>
+        <p:nvSpPr>
+          <p:cNvPr id="15" name="TextBox 14"/>
+          <p:cNvSpPr txBox="1"/>
+          <p:nvPr/>
+        </p:nvSpPr>
+        <p:spPr>
+          <a:xfrm>
+            <a:off x="6507327" y="2999232"/>
+            <a:ext cx="4724247" cy="777240"/>
+          </a:xfrm>
+          <a:prstGeom prst="rect">
+            <a:avLst/>
+          </a:prstGeom>
+          <a:noFill/>
+        </p:spPr>
+        <p:txBody>
+          <a:bodyPr wrap="square" lIns="0" rIns="0" tIns="0" bIns="0" anchor="t">
+            <a:spAutoFit/>
+          </a:bodyPr>
+          <a:lstStyle/>
+          <a:p>
+            <a:pPr algn="l">
+              <a:lnSpc>
+                <a:spcPct val="112000"/>
+              </a:lnSpc>
+              <a:spcAft>
+                <a:spcPts val="0"/>
+              </a:spcAft>
+            </a:pPr>
+            <a:r>
+              <a:rPr sz="1400" b="0">
                 <a:solidFill>
                   <a:srgbClr val="D7D5CE"/>
                 </a:solidFill>
                 <a:latin typeface="Aptos"/>
               </a:rPr>
-              <a:t>Run  bill_report.py  on the log.</a:t>
-            </a:r>
-          </a:p>
-        </p:txBody>
-      </p:sp>
-      <p:sp>
-        <p:nvSpPr>
-          <p:cNvPr id="14" name="Rounded Rectangle 13"/>
+              <a:t>The 128,000-token window fills at turn 80 with or without caching. Only dropping content moves it: turn 337 with old screenshots dropped.</a:t>
+            </a:r>
+          </a:p>
+        </p:txBody>
+      </p:sp>
+      <p:sp>
+        <p:nvSpPr>
+          <p:cNvPr id="16" name="Rounded Rectangle 15"/>
           <p:cNvSpPr/>
           <p:nvPr/>
         </p:nvSpPr>
         <p:spPr>
           <a:xfrm>
-            <a:off x="6135624" y="1737360"/>
-            <a:ext cx="2514600" cy="1874519"/>
+            <a:off x="685800" y="4069080"/>
+            <a:ext cx="5272887" cy="2103120"/>
           </a:xfrm>
           <a:prstGeom prst="roundRect">
             <a:avLst>
@@ -10002,14 +10087,14 @@
       </p:sp>
       <p:sp>
         <p:nvSpPr>
-          <p:cNvPr id="15" name="TextBox 14"/>
+          <p:cNvPr id="17" name="TextBox 16"/>
           <p:cNvSpPr txBox="1"/>
           <p:nvPr/>
         </p:nvSpPr>
         <p:spPr>
           <a:xfrm>
-            <a:off x="6409944" y="1901952"/>
-            <a:ext cx="914400" cy="640080"/>
+            <a:off x="960120" y="4251960"/>
+            <a:ext cx="4724247" cy="731520"/>
           </a:xfrm>
           <a:prstGeom prst="rect">
             <a:avLst/>
@@ -10031,27 +10116,27 @@
               </a:spcAft>
             </a:pPr>
             <a:r>
-              <a:rPr sz="4000" b="1">
+              <a:rPr sz="3800" b="1">
                 <a:solidFill>
                   <a:srgbClr val="5AA3F0"/>
                 </a:solidFill>
                 <a:latin typeface="Aptos Display"/>
               </a:rPr>
-              <a:t>3</a:t>
-            </a:r>
-          </a:p>
-        </p:txBody>
-      </p:sp>
-      <p:sp>
-        <p:nvSpPr>
-          <p:cNvPr id="16" name="TextBox 15"/>
+              <a:t>1,105 to 4,784</a:t>
+            </a:r>
+          </a:p>
+        </p:txBody>
+      </p:sp>
+      <p:sp>
+        <p:nvSpPr>
+          <p:cNvPr id="18" name="TextBox 17"/>
           <p:cNvSpPr txBox="1"/>
           <p:nvPr/>
         </p:nvSpPr>
         <p:spPr>
           <a:xfrm>
-            <a:off x="6409944" y="2651760"/>
-            <a:ext cx="2057400" cy="914400"/>
+            <a:off x="960120" y="4937760"/>
+            <a:ext cx="4724247" cy="365760"/>
           </a:xfrm>
           <a:prstGeom prst="rect">
             <a:avLst/>
@@ -10073,27 +10158,69 @@
               </a:spcAft>
             </a:pPr>
             <a:r>
-              <a:rPr sz="1700" b="0">
+              <a:rPr sz="1900" b="1">
+                <a:solidFill>
+                  <a:srgbClr val="FFFFFF"/>
+                </a:solidFill>
+                <a:latin typeface="Aptos"/>
+              </a:rPr>
+              <a:t>Resolution is a choice, not a fact</a:t>
+            </a:r>
+          </a:p>
+        </p:txBody>
+      </p:sp>
+      <p:sp>
+        <p:nvSpPr>
+          <p:cNvPr id="19" name="TextBox 18"/>
+          <p:cNvSpPr txBox="1"/>
+          <p:nvPr/>
+        </p:nvSpPr>
+        <p:spPr>
+          <a:xfrm>
+            <a:off x="960120" y="5330952"/>
+            <a:ext cx="4724247" cy="777240"/>
+          </a:xfrm>
+          <a:prstGeom prst="rect">
+            <a:avLst/>
+          </a:prstGeom>
+          <a:noFill/>
+        </p:spPr>
+        <p:txBody>
+          <a:bodyPr wrap="square" lIns="0" rIns="0" tIns="0" bIns="0" anchor="t">
+            <a:spAutoFit/>
+          </a:bodyPr>
+          <a:lstStyle/>
+          <a:p>
+            <a:pPr algn="l">
+              <a:lnSpc>
+                <a:spcPct val="112000"/>
+              </a:lnSpc>
+              <a:spcAft>
+                <a:spcPts val="0"/>
+              </a:spcAft>
+            </a:pPr>
+            <a:r>
+              <a:rPr sz="1400" b="0">
                 <a:solidFill>
                   <a:srgbClr val="D7D5CE"/>
                 </a:solidFill>
                 <a:latin typeface="Aptos"/>
               </a:rPr>
-              <a:t>See what dominates: the prefix, or what each turn adds.</a:t>
-            </a:r>
-          </a:p>
-        </p:txBody>
-      </p:sp>
-      <p:sp>
-        <p:nvSpPr>
-          <p:cNvPr id="17" name="Rounded Rectangle 16"/>
+              <a:t>One 4K screenshot: 1,105 on OpenAI's rule, 1,560 on Claude standard, 4,784 on Claude high-resolution. Measure at the size you ship.</a:t>
+            </a:r>
+          </a:p>
+        </p:txBody>
+      </p:sp>
+      <p:sp>
+        <p:nvSpPr>
+          <p:cNvPr id="20" name="Rounded Rectangle 19"/>
           <p:cNvSpPr/>
           <p:nvPr/>
         </p:nvSpPr>
         <p:spPr>
           <a:xfrm>
-            <a:off x="8860536" y="1737360"/>
-            <a:ext cx="2514600" cy="1874519"/>
+            <a:off x="6233007" y="4069080"/>
+            <a:ext cx="5272887" cy="2103120"/>
           </a:xfrm>
           <a:prstGeom prst="roundRect">
             <a:avLst>
@@ -10132,14 +10259,14 @@
       </p:sp>
       <p:sp>
         <p:nvSpPr>
-          <p:cNvPr id="18" name="TextBox 17"/>
+          <p:cNvPr id="21" name="TextBox 20"/>
           <p:cNvSpPr txBox="1"/>
           <p:nvPr/>
         </p:nvSpPr>
         <p:spPr>
           <a:xfrm>
-            <a:off x="9134856" y="1901952"/>
-            <a:ext cx="914400" cy="640080"/>
+            <a:off x="6507327" y="4251960"/>
+            <a:ext cx="4724247" cy="731520"/>
           </a:xfrm>
           <a:prstGeom prst="rect">
             <a:avLst/>
@@ -10161,27 +10288,27 @@
               </a:spcAft>
             </a:pPr>
             <a:r>
-              <a:rPr sz="4000" b="1">
-                <a:solidFill>
-                  <a:srgbClr val="5AA3F0"/>
+              <a:rPr sz="3800" b="1">
+                <a:solidFill>
+                  <a:srgbClr val="F0834E"/>
                 </a:solidFill>
                 <a:latin typeface="Aptos Display"/>
               </a:rPr>
-              <a:t>4</a:t>
-            </a:r>
-          </a:p>
-        </p:txBody>
-      </p:sp>
-      <p:sp>
-        <p:nvSpPr>
-          <p:cNvPr id="19" name="TextBox 18"/>
+              <a:t>1.4% to 33.2%</a:t>
+            </a:r>
+          </a:p>
+        </p:txBody>
+      </p:sp>
+      <p:sp>
+        <p:nvSpPr>
+          <p:cNvPr id="22" name="TextBox 21"/>
           <p:cNvSpPr txBox="1"/>
           <p:nvPr/>
         </p:nvSpPr>
         <p:spPr>
           <a:xfrm>
-            <a:off x="9134856" y="2651760"/>
-            <a:ext cx="2057400" cy="914400"/>
+            <a:off x="6507327" y="4937760"/>
+            <a:ext cx="4724247" cy="365760"/>
           </a:xfrm>
           <a:prstGeom prst="rect">
             <a:avLst/>
@@ -10203,27 +10330,27 @@
               </a:spcAft>
             </a:pPr>
             <a:r>
-              <a:rPr sz="1700" b="0">
-                <a:solidFill>
-                  <a:srgbClr val="D7D5CE"/>
-                </a:solidFill>
-                <a:latin typeface="Aptos"/>
-              </a:rPr>
-              <a:t>Pick the fix aimed at that one.</a:t>
-            </a:r>
-          </a:p>
-        </p:txBody>
-      </p:sp>
-      <p:sp>
-        <p:nvSpPr>
-          <p:cNvPr id="20" name="TextBox 19"/>
+              <a:rPr sz="1900" b="1">
+                <a:solidFill>
+                  <a:srgbClr val="FFFFFF"/>
+                </a:solidFill>
+                <a:latin typeface="Aptos"/>
+              </a:rPr>
+              <a:t>The same fix, two agents</a:t>
+            </a:r>
+          </a:p>
+        </p:txBody>
+      </p:sp>
+      <p:sp>
+        <p:nvSpPr>
+          <p:cNvPr id="23" name="TextBox 22"/>
           <p:cNvSpPr txBox="1"/>
           <p:nvPr/>
         </p:nvSpPr>
         <p:spPr>
           <a:xfrm>
-            <a:off x="685800" y="3977639"/>
-            <a:ext cx="6949440" cy="2011680"/>
+            <a:off x="6507327" y="5330952"/>
+            <a:ext cx="4724247" cy="777240"/>
           </a:xfrm>
           <a:prstGeom prst="rect">
             <a:avLst/>
@@ -10238,115 +10365,34 @@
           <a:p>
             <a:pPr algn="l">
               <a:lnSpc>
-                <a:spcPct val="130000"/>
-              </a:lnSpc>
-              <a:spcAft>
-                <a:spcPts val="0"/>
-              </a:spcAft>
-            </a:pPr>
-            <a:r>
-              <a:rPr sz="2200" b="1">
-                <a:solidFill>
-                  <a:srgbClr val="FFFFFF"/>
-                </a:solidFill>
-                <a:latin typeface="Aptos"/>
-              </a:rPr>
-              <a:t>Your bill = size  ×  sends  ×  price per send</a:t>
-            </a:r>
-          </a:p>
-          <a:p>
-            <a:pPr algn="l">
-              <a:lnSpc>
-                <a:spcPct val="130000"/>
-              </a:lnSpc>
-              <a:spcAft>
-                <a:spcPts val="0"/>
-              </a:spcAft>
-            </a:pPr>
-            <a:r>
-              <a:rPr sz="2000" b="0">
-                <a:solidFill>
-                  <a:srgbClr val="B5B2AA"/>
-                </a:solidFill>
-                <a:latin typeface="Aptos"/>
-              </a:rPr>
-              <a:t>The best fix changes with:</a:t>
-            </a:r>
-          </a:p>
-          <a:p>
-            <a:pPr algn="l">
-              <a:lnSpc>
-                <a:spcPct val="130000"/>
-              </a:lnSpc>
-              <a:spcAft>
-                <a:spcPts val="0"/>
-              </a:spcAft>
-            </a:pPr>
-            <a:r>
-              <a:rPr sz="2000" b="1">
-                <a:solidFill>
-                  <a:srgbClr val="5AA3F0"/>
-                </a:solidFill>
-                <a:latin typeface="Aptos"/>
-              </a:rPr>
-              <a:t>caching · session length · prompt size · pictures</a:t>
-            </a:r>
-          </a:p>
-          <a:p>
-            <a:pPr algn="l">
-              <a:lnSpc>
-                <a:spcPct val="130000"/>
-              </a:lnSpc>
-              <a:spcAft>
-                <a:spcPts val="0"/>
-              </a:spcAft>
-            </a:pPr>
-            <a:r>
-              <a:rPr sz="1800" b="0">
-                <a:solidFill>
-                  <a:srgbClr val="B5B2AA"/>
-                </a:solidFill>
-                <a:latin typeface="Aptos"/>
-              </a:rPr>
-              <a:t>So measure yours first.</a:t>
-            </a:r>
-          </a:p>
-        </p:txBody>
-      </p:sp>
-      <p:pic>
-        <p:nvPicPr>
-          <p:cNvPr id="21" name="Picture 20" descr="qr_dark.png"/>
-          <p:cNvPicPr>
-            <a:picLocks noChangeAspect="1"/>
-          </p:cNvPicPr>
-          <p:nvPr/>
-        </p:nvPicPr>
-        <p:blipFill>
-          <a:blip r:embed="rId2"/>
-          <a:stretch>
-            <a:fillRect/>
-          </a:stretch>
-        </p:blipFill>
-        <p:spPr>
-          <a:xfrm>
-            <a:off x="9921240" y="3931920"/>
-            <a:ext cx="1600200" cy="1600200"/>
-          </a:xfrm>
-          <a:prstGeom prst="rect">
-            <a:avLst/>
-          </a:prstGeom>
-        </p:spPr>
-      </p:pic>
-      <p:sp>
-        <p:nvSpPr>
-          <p:cNvPr id="22" name="TextBox 21"/>
+                <a:spcPct val="112000"/>
+              </a:lnSpc>
+              <a:spcAft>
+                <a:spcPts val="0"/>
+              </a:spcAft>
+            </a:pPr>
+            <a:r>
+              <a:rPr sz="1400" b="0">
+                <a:solidFill>
+                  <a:srgbClr val="D7D5CE"/>
+                </a:solidFill>
+                <a:latin typeface="Aptos"/>
+              </a:rPr>
+              <a:t>Cutting the system prompt on a screen agent, then on a chat agent. The shape of your bill picks the fix.</a:t>
+            </a:r>
+          </a:p>
+        </p:txBody>
+      </p:sp>
+      <p:sp>
+        <p:nvSpPr>
+          <p:cNvPr id="24" name="TextBox 23"/>
           <p:cNvSpPr txBox="1"/>
           <p:nvPr/>
         </p:nvSpPr>
         <p:spPr>
           <a:xfrm>
-            <a:off x="7223760" y="4023360"/>
-            <a:ext cx="2514600" cy="1737360"/>
+            <a:off x="685800" y="6473952"/>
+            <a:ext cx="5486400" cy="274320"/>
           </a:xfrm>
           <a:prstGeom prst="rect">
             <a:avLst/>
@@ -10359,7 +10405,7 @@
           </a:bodyPr>
           <a:lstStyle/>
           <a:p>
-            <a:pPr algn="r">
+            <a:pPr algn="l">
               <a:lnSpc>
                 <a:spcPct val="108000"/>
               </a:lnSpc>
@@ -10368,103 +10414,27 @@
               </a:spcAft>
             </a:pPr>
             <a:r>
-              <a:rPr sz="3200" b="1">
-                <a:solidFill>
-                  <a:srgbClr val="FFFFFF"/>
-                </a:solidFill>
-                <a:latin typeface="Aptos Display"/>
-              </a:rPr>
-              <a:t>Thank you</a:t>
-            </a:r>
-          </a:p>
-          <a:p>
-            <a:pPr algn="r">
-              <a:lnSpc>
-                <a:spcPct val="108000"/>
-              </a:lnSpc>
-              <a:spcAft>
-                <a:spcPts val="0"/>
-              </a:spcAft>
-            </a:pPr>
-            <a:r>
-              <a:rPr sz="1700" b="1">
-                <a:solidFill>
-                  <a:srgbClr val="FFFFFF"/>
-                </a:solidFill>
-                <a:latin typeface="Aptos"/>
-              </a:rPr>
-              <a:t>Shyamji Tiwari</a:t>
-            </a:r>
-          </a:p>
-          <a:p>
-            <a:pPr algn="r">
-              <a:lnSpc>
-                <a:spcPct val="108000"/>
-              </a:lnSpc>
-              <a:spcAft>
-                <a:spcPts val="0"/>
-              </a:spcAft>
-            </a:pPr>
-            <a:r>
-              <a:rPr sz="1400" b="0">
-                <a:solidFill>
-                  <a:srgbClr val="D7D5CE"/>
-                </a:solidFill>
-                <a:latin typeface="Aptos"/>
-              </a:rPr>
-              <a:t>Applied Scientist, Amazon</a:t>
-            </a:r>
-          </a:p>
-          <a:p>
-            <a:pPr algn="r">
-              <a:lnSpc>
-                <a:spcPct val="108000"/>
-              </a:lnSpc>
-              <a:spcAft>
-                <a:spcPts val="0"/>
-              </a:spcAft>
-            </a:pPr>
-            <a:r>
-              <a:rPr sz="1200" b="0">
-                <a:solidFill>
-                  <a:srgbClr val="5AA3F0"/>
-                </a:solidFill>
-                <a:latin typeface="Aptos"/>
-              </a:rPr>
-              <a:t>github.com/ieee-ai/agentic-ai-26</a:t>
-            </a:r>
-          </a:p>
-          <a:p>
-            <a:pPr algn="r">
-              <a:lnSpc>
-                <a:spcPct val="108000"/>
-              </a:lnSpc>
-              <a:spcAft>
-                <a:spcPts val="0"/>
-              </a:spcAft>
-            </a:pPr>
-            <a:r>
-              <a:rPr sz="1200" b="0">
-                <a:solidFill>
-                  <a:srgbClr val="5AA3F0"/>
-                </a:solidFill>
-                <a:latin typeface="Aptos"/>
-              </a:rPr>
-              <a:t>/Saving-the-Tokens</a:t>
-            </a:r>
-          </a:p>
-        </p:txBody>
-      </p:sp>
-      <p:sp>
-        <p:nvSpPr>
-          <p:cNvPr id="23" name="TextBox 22"/>
+              <a:rPr sz="1100" b="0">
+                <a:solidFill>
+                  <a:srgbClr val="B5B2AA"/>
+                </a:solidFill>
+                <a:latin typeface="Aptos"/>
+              </a:rPr>
+              <a:t>Saving the Tokens  ·  Shyamji Tiwari</a:t>
+            </a:r>
+          </a:p>
+        </p:txBody>
+      </p:sp>
+      <p:sp>
+        <p:nvSpPr>
+          <p:cNvPr id="25" name="TextBox 24"/>
           <p:cNvSpPr txBox="1"/>
           <p:nvPr/>
         </p:nvSpPr>
         <p:spPr>
           <a:xfrm>
-            <a:off x="685800" y="6473952"/>
-            <a:ext cx="5486400" cy="274320"/>
+            <a:off x="5760720" y="6473952"/>
+            <a:ext cx="5745175" cy="274320"/>
           </a:xfrm>
           <a:prstGeom prst="rect">
             <a:avLst/>
@@ -10477,7 +10447,7 @@
           </a:bodyPr>
           <a:lstStyle/>
           <a:p>
-            <a:pPr algn="l">
+            <a:pPr algn="r">
               <a:lnSpc>
                 <a:spcPct val="108000"/>
               </a:lnSpc>
@@ -10492,49 +10462,7 @@
                 </a:solidFill>
                 <a:latin typeface="Aptos"/>
               </a:rPr>
-              <a:t>Saving the Tokens  ·  Shyamji Tiwari</a:t>
-            </a:r>
-          </a:p>
-        </p:txBody>
-      </p:sp>
-      <p:sp>
-        <p:nvSpPr>
-          <p:cNvPr id="24" name="TextBox 23"/>
-          <p:cNvSpPr txBox="1"/>
-          <p:nvPr/>
-        </p:nvSpPr>
-        <p:spPr>
-          <a:xfrm>
-            <a:off x="5760720" y="6473952"/>
-            <a:ext cx="5745175" cy="274320"/>
-          </a:xfrm>
-          <a:prstGeom prst="rect">
-            <a:avLst/>
-          </a:prstGeom>
-          <a:noFill/>
-        </p:spPr>
-        <p:txBody>
-          <a:bodyPr wrap="square" lIns="0" rIns="0" tIns="0" bIns="0" anchor="t">
-            <a:spAutoFit/>
-          </a:bodyPr>
-          <a:lstStyle/>
-          <a:p>
-            <a:pPr algn="r">
-              <a:lnSpc>
-                <a:spcPct val="108000"/>
-              </a:lnSpc>
-              <a:spcAft>
-                <a:spcPts val="0"/>
-              </a:spcAft>
-            </a:pPr>
-            <a:r>
-              <a:rPr sz="1100" b="0">
-                <a:solidFill>
-                  <a:srgbClr val="B5B2AA"/>
-                </a:solidFill>
-                <a:latin typeface="Aptos"/>
-              </a:rPr>
-              <a:t>Simulated 20-turn session · illustrative settings · input tokens only</a:t>
+              <a:t>cards 1, 2, 4: example agent · card 3: published rules, checked 2026-10-29</a:t>
             </a:r>
           </a:p>
         </p:txBody>
@@ -11498,6 +11426,1214 @@
               <a:rPr sz="1100" b="0">
                 <a:solidFill>
                   <a:srgbClr val="6B6963"/>
+                </a:solidFill>
+                <a:latin typeface="Aptos"/>
+              </a:rPr>
+              <a:t>Saving the Tokens  ·  Shyamji Tiwari</a:t>
+            </a:r>
+          </a:p>
+        </p:txBody>
+      </p:sp>
+    </p:spTree>
+  </p:cSld>
+  <p:clrMapOvr>
+    <a:masterClrMapping/>
+  </p:clrMapOvr>
+</p:sld>
+</file>
+
+<file path=ppt/slides/slide20.xml><?xml version="1.0" encoding="utf-8"?>
+<p:sld xmlns:a="http://schemas.openxmlformats.org/drawingml/2006/main" xmlns:p="http://schemas.openxmlformats.org/presentationml/2006/main" xmlns:r="http://schemas.openxmlformats.org/officeDocument/2006/relationships">
+  <p:cSld>
+    <p:bg>
+      <p:bgPr>
+        <a:solidFill>
+          <a:srgbClr val="121212"/>
+        </a:solidFill>
+        <a:effectLst/>
+      </p:bgPr>
+    </p:bg>
+    <p:spTree>
+      <p:nvGrpSpPr>
+        <p:cNvPr id="1" name=""/>
+        <p:cNvGrpSpPr/>
+        <p:nvPr/>
+      </p:nvGrpSpPr>
+      <p:grpSpPr/>
+      <p:sp>
+        <p:nvSpPr>
+          <p:cNvPr id="2" name="TextBox 1"/>
+          <p:cNvSpPr txBox="1"/>
+          <p:nvPr/>
+        </p:nvSpPr>
+        <p:spPr>
+          <a:xfrm>
+            <a:off x="685800" y="457200"/>
+            <a:ext cx="5486400" cy="320040"/>
+          </a:xfrm>
+          <a:prstGeom prst="rect">
+            <a:avLst/>
+          </a:prstGeom>
+          <a:noFill/>
+        </p:spPr>
+        <p:txBody>
+          <a:bodyPr wrap="square" lIns="0" rIns="0" tIns="0" bIns="0" anchor="t">
+            <a:spAutoFit/>
+          </a:bodyPr>
+          <a:lstStyle/>
+          <a:p>
+            <a:pPr algn="l">
+              <a:lnSpc>
+                <a:spcPct val="108000"/>
+              </a:lnSpc>
+              <a:spcAft>
+                <a:spcPts val="0"/>
+              </a:spcAft>
+            </a:pPr>
+            <a:r>
+              <a:rPr sz="1400" b="1">
+                <a:solidFill>
+                  <a:srgbClr val="B5B2AA"/>
+                </a:solidFill>
+                <a:latin typeface="Aptos"/>
+              </a:rPr>
+              <a:t>TAKE THIS WITH YOU</a:t>
+            </a:r>
+          </a:p>
+        </p:txBody>
+      </p:sp>
+      <p:sp>
+        <p:nvSpPr>
+          <p:cNvPr id="3" name="Rounded Rectangle 2"/>
+          <p:cNvSpPr/>
+          <p:nvPr/>
+        </p:nvSpPr>
+        <p:spPr>
+          <a:xfrm>
+            <a:off x="10262311" y="548640"/>
+            <a:ext cx="256032" cy="64008"/>
+          </a:xfrm>
+          <a:prstGeom prst="roundRect">
+            <a:avLst>
+              <a:gd name="adj" fmla="val 50000"/>
+            </a:avLst>
+          </a:prstGeom>
+          <a:solidFill>
+            <a:srgbClr val="3A3A38"/>
+          </a:solidFill>
+          <a:ln>
+            <a:noFill/>
+          </a:ln>
+          <a:effectLst/>
+        </p:spPr>
+        <p:style>
+          <a:lnRef idx="1">
+            <a:schemeClr val="accent1"/>
+          </a:lnRef>
+          <a:fillRef idx="3">
+            <a:schemeClr val="accent1"/>
+          </a:fillRef>
+          <a:effectRef idx="2">
+            <a:schemeClr val="accent1"/>
+          </a:effectRef>
+          <a:fontRef idx="minor">
+            <a:schemeClr val="lt1"/>
+          </a:fontRef>
+        </p:style>
+        <p:txBody>
+          <a:bodyPr rtlCol="0" anchor="ctr"/>
+          <a:lstStyle/>
+          <a:p>
+            <a:pPr algn="ctr"/>
+          </a:p>
+        </p:txBody>
+      </p:sp>
+      <p:sp>
+        <p:nvSpPr>
+          <p:cNvPr id="4" name="Rounded Rectangle 3"/>
+          <p:cNvSpPr/>
+          <p:nvPr/>
+        </p:nvSpPr>
+        <p:spPr>
+          <a:xfrm>
+            <a:off x="10591495" y="548640"/>
+            <a:ext cx="256032" cy="64008"/>
+          </a:xfrm>
+          <a:prstGeom prst="roundRect">
+            <a:avLst>
+              <a:gd name="adj" fmla="val 50000"/>
+            </a:avLst>
+          </a:prstGeom>
+          <a:solidFill>
+            <a:srgbClr val="3A3A38"/>
+          </a:solidFill>
+          <a:ln>
+            <a:noFill/>
+          </a:ln>
+          <a:effectLst/>
+        </p:spPr>
+        <p:style>
+          <a:lnRef idx="1">
+            <a:schemeClr val="accent1"/>
+          </a:lnRef>
+          <a:fillRef idx="3">
+            <a:schemeClr val="accent1"/>
+          </a:fillRef>
+          <a:effectRef idx="2">
+            <a:schemeClr val="accent1"/>
+          </a:effectRef>
+          <a:fontRef idx="minor">
+            <a:schemeClr val="lt1"/>
+          </a:fontRef>
+        </p:style>
+        <p:txBody>
+          <a:bodyPr rtlCol="0" anchor="ctr"/>
+          <a:lstStyle/>
+          <a:p>
+            <a:pPr algn="ctr"/>
+          </a:p>
+        </p:txBody>
+      </p:sp>
+      <p:sp>
+        <p:nvSpPr>
+          <p:cNvPr id="5" name="Rounded Rectangle 4"/>
+          <p:cNvSpPr/>
+          <p:nvPr/>
+        </p:nvSpPr>
+        <p:spPr>
+          <a:xfrm>
+            <a:off x="10920679" y="548640"/>
+            <a:ext cx="256032" cy="64008"/>
+          </a:xfrm>
+          <a:prstGeom prst="roundRect">
+            <a:avLst>
+              <a:gd name="adj" fmla="val 50000"/>
+            </a:avLst>
+          </a:prstGeom>
+          <a:solidFill>
+            <a:srgbClr val="3A3A38"/>
+          </a:solidFill>
+          <a:ln>
+            <a:noFill/>
+          </a:ln>
+          <a:effectLst/>
+        </p:spPr>
+        <p:style>
+          <a:lnRef idx="1">
+            <a:schemeClr val="accent1"/>
+          </a:lnRef>
+          <a:fillRef idx="3">
+            <a:schemeClr val="accent1"/>
+          </a:fillRef>
+          <a:effectRef idx="2">
+            <a:schemeClr val="accent1"/>
+          </a:effectRef>
+          <a:fontRef idx="minor">
+            <a:schemeClr val="lt1"/>
+          </a:fontRef>
+        </p:style>
+        <p:txBody>
+          <a:bodyPr rtlCol="0" anchor="ctr"/>
+          <a:lstStyle/>
+          <a:p>
+            <a:pPr algn="ctr"/>
+          </a:p>
+        </p:txBody>
+      </p:sp>
+      <p:sp>
+        <p:nvSpPr>
+          <p:cNvPr id="6" name="Rounded Rectangle 5"/>
+          <p:cNvSpPr/>
+          <p:nvPr/>
+        </p:nvSpPr>
+        <p:spPr>
+          <a:xfrm>
+            <a:off x="11249863" y="548640"/>
+            <a:ext cx="256032" cy="64008"/>
+          </a:xfrm>
+          <a:prstGeom prst="roundRect">
+            <a:avLst>
+              <a:gd name="adj" fmla="val 50000"/>
+            </a:avLst>
+          </a:prstGeom>
+          <a:solidFill>
+            <a:srgbClr val="5AA3F0"/>
+          </a:solidFill>
+          <a:ln>
+            <a:noFill/>
+          </a:ln>
+          <a:effectLst/>
+        </p:spPr>
+        <p:style>
+          <a:lnRef idx="1">
+            <a:schemeClr val="accent1"/>
+          </a:lnRef>
+          <a:fillRef idx="3">
+            <a:schemeClr val="accent1"/>
+          </a:fillRef>
+          <a:effectRef idx="2">
+            <a:schemeClr val="accent1"/>
+          </a:effectRef>
+          <a:fontRef idx="minor">
+            <a:schemeClr val="lt1"/>
+          </a:fontRef>
+        </p:style>
+        <p:txBody>
+          <a:bodyPr rtlCol="0" anchor="ctr"/>
+          <a:lstStyle/>
+          <a:p>
+            <a:pPr algn="ctr"/>
+          </a:p>
+        </p:txBody>
+      </p:sp>
+      <p:sp>
+        <p:nvSpPr>
+          <p:cNvPr id="7" name="TextBox 6"/>
+          <p:cNvSpPr txBox="1"/>
+          <p:nvPr/>
+        </p:nvSpPr>
+        <p:spPr>
+          <a:xfrm>
+            <a:off x="685800" y="841248"/>
+            <a:ext cx="10820095" cy="914400"/>
+          </a:xfrm>
+          <a:prstGeom prst="rect">
+            <a:avLst/>
+          </a:prstGeom>
+          <a:noFill/>
+        </p:spPr>
+        <p:txBody>
+          <a:bodyPr wrap="square" lIns="0" rIns="0" tIns="0" bIns="0" anchor="t">
+            <a:spAutoFit/>
+          </a:bodyPr>
+          <a:lstStyle/>
+          <a:p>
+            <a:pPr algn="l">
+              <a:lnSpc>
+                <a:spcPct val="95000"/>
+              </a:lnSpc>
+              <a:spcAft>
+                <a:spcPts val="0"/>
+              </a:spcAft>
+            </a:pPr>
+            <a:r>
+              <a:rPr sz="4000" b="1">
+                <a:solidFill>
+                  <a:srgbClr val="FFFFFF"/>
+                </a:solidFill>
+                <a:latin typeface="Aptos Display"/>
+              </a:rPr>
+              <a:t>Four questions to ask your own agent</a:t>
+            </a:r>
+          </a:p>
+        </p:txBody>
+      </p:sp>
+      <p:sp>
+        <p:nvSpPr>
+          <p:cNvPr id="8" name="Rounded Rectangle 7"/>
+          <p:cNvSpPr/>
+          <p:nvPr/>
+        </p:nvSpPr>
+        <p:spPr>
+          <a:xfrm>
+            <a:off x="685800" y="1737360"/>
+            <a:ext cx="7223760" cy="1024128"/>
+          </a:xfrm>
+          <a:prstGeom prst="roundRect">
+            <a:avLst>
+              <a:gd name="adj" fmla="val 7000"/>
+            </a:avLst>
+          </a:prstGeom>
+          <a:solidFill>
+            <a:srgbClr val="1F1F1D"/>
+          </a:solidFill>
+          <a:ln>
+            <a:noFill/>
+          </a:ln>
+          <a:effectLst/>
+        </p:spPr>
+        <p:style>
+          <a:lnRef idx="1">
+            <a:schemeClr val="accent1"/>
+          </a:lnRef>
+          <a:fillRef idx="3">
+            <a:schemeClr val="accent1"/>
+          </a:fillRef>
+          <a:effectRef idx="2">
+            <a:schemeClr val="accent1"/>
+          </a:effectRef>
+          <a:fontRef idx="minor">
+            <a:schemeClr val="lt1"/>
+          </a:fontRef>
+        </p:style>
+        <p:txBody>
+          <a:bodyPr rtlCol="0" anchor="ctr"/>
+          <a:lstStyle/>
+          <a:p>
+            <a:pPr algn="ctr"/>
+          </a:p>
+        </p:txBody>
+      </p:sp>
+      <p:sp>
+        <p:nvSpPr>
+          <p:cNvPr id="9" name="TextBox 8"/>
+          <p:cNvSpPr txBox="1"/>
+          <p:nvPr/>
+        </p:nvSpPr>
+        <p:spPr>
+          <a:xfrm>
+            <a:off x="960120" y="1901952"/>
+            <a:ext cx="548640" cy="640080"/>
+          </a:xfrm>
+          <a:prstGeom prst="rect">
+            <a:avLst/>
+          </a:prstGeom>
+          <a:noFill/>
+        </p:spPr>
+        <p:txBody>
+          <a:bodyPr wrap="square" lIns="0" rIns="0" tIns="0" bIns="0" anchor="t">
+            <a:spAutoFit/>
+          </a:bodyPr>
+          <a:lstStyle/>
+          <a:p>
+            <a:pPr algn="l">
+              <a:lnSpc>
+                <a:spcPct val="108000"/>
+              </a:lnSpc>
+              <a:spcAft>
+                <a:spcPts val="0"/>
+              </a:spcAft>
+            </a:pPr>
+            <a:r>
+              <a:rPr sz="3400" b="1">
+                <a:solidFill>
+                  <a:srgbClr val="5AA3F0"/>
+                </a:solidFill>
+                <a:latin typeface="Aptos Display"/>
+              </a:rPr>
+              <a:t>1</a:t>
+            </a:r>
+          </a:p>
+        </p:txBody>
+      </p:sp>
+      <p:sp>
+        <p:nvSpPr>
+          <p:cNvPr id="10" name="TextBox 9"/>
+          <p:cNvSpPr txBox="1"/>
+          <p:nvPr/>
+        </p:nvSpPr>
+        <p:spPr>
+          <a:xfrm>
+            <a:off x="1554480" y="1865376"/>
+            <a:ext cx="6217920" cy="365760"/>
+          </a:xfrm>
+          <a:prstGeom prst="rect">
+            <a:avLst/>
+          </a:prstGeom>
+          <a:noFill/>
+        </p:spPr>
+        <p:txBody>
+          <a:bodyPr wrap="square" lIns="0" rIns="0" tIns="0" bIns="0" anchor="t">
+            <a:spAutoFit/>
+          </a:bodyPr>
+          <a:lstStyle/>
+          <a:p>
+            <a:pPr algn="l">
+              <a:lnSpc>
+                <a:spcPct val="108000"/>
+              </a:lnSpc>
+              <a:spcAft>
+                <a:spcPts val="0"/>
+              </a:spcAft>
+            </a:pPr>
+            <a:r>
+              <a:rPr sz="1900" b="1">
+                <a:solidFill>
+                  <a:srgbClr val="FFFFFF"/>
+                </a:solidFill>
+                <a:latin typeface="Aptos"/>
+              </a:rPr>
+              <a:t>What share of my input is cache reads?</a:t>
+            </a:r>
+          </a:p>
+        </p:txBody>
+      </p:sp>
+      <p:sp>
+        <p:nvSpPr>
+          <p:cNvPr id="11" name="TextBox 10"/>
+          <p:cNvSpPr txBox="1"/>
+          <p:nvPr/>
+        </p:nvSpPr>
+        <p:spPr>
+          <a:xfrm>
+            <a:off x="1554480" y="2240280"/>
+            <a:ext cx="6217920" cy="502920"/>
+          </a:xfrm>
+          <a:prstGeom prst="rect">
+            <a:avLst/>
+          </a:prstGeom>
+          <a:noFill/>
+        </p:spPr>
+        <p:txBody>
+          <a:bodyPr wrap="square" lIns="0" rIns="0" tIns="0" bIns="0" anchor="t">
+            <a:spAutoFit/>
+          </a:bodyPr>
+          <a:lstStyle/>
+          <a:p>
+            <a:pPr algn="l">
+              <a:lnSpc>
+                <a:spcPct val="110000"/>
+              </a:lnSpc>
+              <a:spcAft>
+                <a:spcPts val="0"/>
+              </a:spcAft>
+            </a:pPr>
+            <a:r>
+              <a:rPr sz="1400" b="0">
+                <a:solidFill>
+                  <a:srgbClr val="D7D5CE"/>
+                </a:solidFill>
+                <a:latin typeface="Aptos"/>
+              </a:rPr>
+              <a:t>From the usage field. Near zero means you pay full price for every repeat.</a:t>
+            </a:r>
+          </a:p>
+        </p:txBody>
+      </p:sp>
+      <p:sp>
+        <p:nvSpPr>
+          <p:cNvPr id="12" name="Rounded Rectangle 11"/>
+          <p:cNvSpPr/>
+          <p:nvPr/>
+        </p:nvSpPr>
+        <p:spPr>
+          <a:xfrm>
+            <a:off x="685800" y="2834640"/>
+            <a:ext cx="7223760" cy="1024128"/>
+          </a:xfrm>
+          <a:prstGeom prst="roundRect">
+            <a:avLst>
+              <a:gd name="adj" fmla="val 7000"/>
+            </a:avLst>
+          </a:prstGeom>
+          <a:solidFill>
+            <a:srgbClr val="1F1F1D"/>
+          </a:solidFill>
+          <a:ln>
+            <a:noFill/>
+          </a:ln>
+          <a:effectLst/>
+        </p:spPr>
+        <p:style>
+          <a:lnRef idx="1">
+            <a:schemeClr val="accent1"/>
+          </a:lnRef>
+          <a:fillRef idx="3">
+            <a:schemeClr val="accent1"/>
+          </a:fillRef>
+          <a:effectRef idx="2">
+            <a:schemeClr val="accent1"/>
+          </a:effectRef>
+          <a:fontRef idx="minor">
+            <a:schemeClr val="lt1"/>
+          </a:fontRef>
+        </p:style>
+        <p:txBody>
+          <a:bodyPr rtlCol="0" anchor="ctr"/>
+          <a:lstStyle/>
+          <a:p>
+            <a:pPr algn="ctr"/>
+          </a:p>
+        </p:txBody>
+      </p:sp>
+      <p:sp>
+        <p:nvSpPr>
+          <p:cNvPr id="13" name="TextBox 12"/>
+          <p:cNvSpPr txBox="1"/>
+          <p:nvPr/>
+        </p:nvSpPr>
+        <p:spPr>
+          <a:xfrm>
+            <a:off x="960120" y="2999232"/>
+            <a:ext cx="548640" cy="640080"/>
+          </a:xfrm>
+          <a:prstGeom prst="rect">
+            <a:avLst/>
+          </a:prstGeom>
+          <a:noFill/>
+        </p:spPr>
+        <p:txBody>
+          <a:bodyPr wrap="square" lIns="0" rIns="0" tIns="0" bIns="0" anchor="t">
+            <a:spAutoFit/>
+          </a:bodyPr>
+          <a:lstStyle/>
+          <a:p>
+            <a:pPr algn="l">
+              <a:lnSpc>
+                <a:spcPct val="108000"/>
+              </a:lnSpc>
+              <a:spcAft>
+                <a:spcPts val="0"/>
+              </a:spcAft>
+            </a:pPr>
+            <a:r>
+              <a:rPr sz="3400" b="1">
+                <a:solidFill>
+                  <a:srgbClr val="5AA3F0"/>
+                </a:solidFill>
+                <a:latin typeface="Aptos Display"/>
+              </a:rPr>
+              <a:t>2</a:t>
+            </a:r>
+          </a:p>
+        </p:txBody>
+      </p:sp>
+      <p:sp>
+        <p:nvSpPr>
+          <p:cNvPr id="14" name="TextBox 13"/>
+          <p:cNvSpPr txBox="1"/>
+          <p:nvPr/>
+        </p:nvSpPr>
+        <p:spPr>
+          <a:xfrm>
+            <a:off x="1554480" y="2962656"/>
+            <a:ext cx="6217920" cy="365760"/>
+          </a:xfrm>
+          <a:prstGeom prst="rect">
+            <a:avLst/>
+          </a:prstGeom>
+          <a:noFill/>
+        </p:spPr>
+        <p:txBody>
+          <a:bodyPr wrap="square" lIns="0" rIns="0" tIns="0" bIns="0" anchor="t">
+            <a:spAutoFit/>
+          </a:bodyPr>
+          <a:lstStyle/>
+          <a:p>
+            <a:pPr algn="l">
+              <a:lnSpc>
+                <a:spcPct val="108000"/>
+              </a:lnSpc>
+              <a:spcAft>
+                <a:spcPts val="0"/>
+              </a:spcAft>
+            </a:pPr>
+            <a:r>
+              <a:rPr sz="1900" b="1">
+                <a:solidFill>
+                  <a:srgbClr val="FFFFFF"/>
+                </a:solidFill>
+                <a:latin typeface="Aptos"/>
+              </a:rPr>
+              <a:t>What changes at the start of my prompt?</a:t>
+            </a:r>
+          </a:p>
+        </p:txBody>
+      </p:sp>
+      <p:sp>
+        <p:nvSpPr>
+          <p:cNvPr id="15" name="TextBox 14"/>
+          <p:cNvSpPr txBox="1"/>
+          <p:nvPr/>
+        </p:nvSpPr>
+        <p:spPr>
+          <a:xfrm>
+            <a:off x="1554480" y="3337560"/>
+            <a:ext cx="6217920" cy="502920"/>
+          </a:xfrm>
+          <a:prstGeom prst="rect">
+            <a:avLst/>
+          </a:prstGeom>
+          <a:noFill/>
+        </p:spPr>
+        <p:txBody>
+          <a:bodyPr wrap="square" lIns="0" rIns="0" tIns="0" bIns="0" anchor="t">
+            <a:spAutoFit/>
+          </a:bodyPr>
+          <a:lstStyle/>
+          <a:p>
+            <a:pPr algn="l">
+              <a:lnSpc>
+                <a:spcPct val="110000"/>
+              </a:lnSpc>
+              <a:spcAft>
+                <a:spcPts val="0"/>
+              </a:spcAft>
+            </a:pPr>
+            <a:r>
+              <a:rPr sz="1400" b="0">
+                <a:solidFill>
+                  <a:srgbClr val="D7D5CE"/>
+                </a:solidFill>
+                <a:latin typeface="Aptos"/>
+              </a:rPr>
+              <a:t>A timestamp, a reordered tool list, a dropped message: it voids the cache from that point.</a:t>
+            </a:r>
+          </a:p>
+        </p:txBody>
+      </p:sp>
+      <p:sp>
+        <p:nvSpPr>
+          <p:cNvPr id="16" name="Rounded Rectangle 15"/>
+          <p:cNvSpPr/>
+          <p:nvPr/>
+        </p:nvSpPr>
+        <p:spPr>
+          <a:xfrm>
+            <a:off x="685800" y="3931920"/>
+            <a:ext cx="7223760" cy="1024128"/>
+          </a:xfrm>
+          <a:prstGeom prst="roundRect">
+            <a:avLst>
+              <a:gd name="adj" fmla="val 7000"/>
+            </a:avLst>
+          </a:prstGeom>
+          <a:solidFill>
+            <a:srgbClr val="1F1F1D"/>
+          </a:solidFill>
+          <a:ln>
+            <a:noFill/>
+          </a:ln>
+          <a:effectLst/>
+        </p:spPr>
+        <p:style>
+          <a:lnRef idx="1">
+            <a:schemeClr val="accent1"/>
+          </a:lnRef>
+          <a:fillRef idx="3">
+            <a:schemeClr val="accent1"/>
+          </a:fillRef>
+          <a:effectRef idx="2">
+            <a:schemeClr val="accent1"/>
+          </a:effectRef>
+          <a:fontRef idx="minor">
+            <a:schemeClr val="lt1"/>
+          </a:fontRef>
+        </p:style>
+        <p:txBody>
+          <a:bodyPr rtlCol="0" anchor="ctr"/>
+          <a:lstStyle/>
+          <a:p>
+            <a:pPr algn="ctr"/>
+          </a:p>
+        </p:txBody>
+      </p:sp>
+      <p:sp>
+        <p:nvSpPr>
+          <p:cNvPr id="17" name="TextBox 16"/>
+          <p:cNvSpPr txBox="1"/>
+          <p:nvPr/>
+        </p:nvSpPr>
+        <p:spPr>
+          <a:xfrm>
+            <a:off x="960120" y="4096512"/>
+            <a:ext cx="548640" cy="640080"/>
+          </a:xfrm>
+          <a:prstGeom prst="rect">
+            <a:avLst/>
+          </a:prstGeom>
+          <a:noFill/>
+        </p:spPr>
+        <p:txBody>
+          <a:bodyPr wrap="square" lIns="0" rIns="0" tIns="0" bIns="0" anchor="t">
+            <a:spAutoFit/>
+          </a:bodyPr>
+          <a:lstStyle/>
+          <a:p>
+            <a:pPr algn="l">
+              <a:lnSpc>
+                <a:spcPct val="108000"/>
+              </a:lnSpc>
+              <a:spcAft>
+                <a:spcPts val="0"/>
+              </a:spcAft>
+            </a:pPr>
+            <a:r>
+              <a:rPr sz="3400" b="1">
+                <a:solidFill>
+                  <a:srgbClr val="5AA3F0"/>
+                </a:solidFill>
+                <a:latin typeface="Aptos Display"/>
+              </a:rPr>
+              <a:t>3</a:t>
+            </a:r>
+          </a:p>
+        </p:txBody>
+      </p:sp>
+      <p:sp>
+        <p:nvSpPr>
+          <p:cNvPr id="18" name="TextBox 17"/>
+          <p:cNvSpPr txBox="1"/>
+          <p:nvPr/>
+        </p:nvSpPr>
+        <p:spPr>
+          <a:xfrm>
+            <a:off x="1554480" y="4059936"/>
+            <a:ext cx="6217920" cy="365760"/>
+          </a:xfrm>
+          <a:prstGeom prst="rect">
+            <a:avLst/>
+          </a:prstGeom>
+          <a:noFill/>
+        </p:spPr>
+        <p:txBody>
+          <a:bodyPr wrap="square" lIns="0" rIns="0" tIns="0" bIns="0" anchor="t">
+            <a:spAutoFit/>
+          </a:bodyPr>
+          <a:lstStyle/>
+          <a:p>
+            <a:pPr algn="l">
+              <a:lnSpc>
+                <a:spcPct val="108000"/>
+              </a:lnSpc>
+              <a:spcAft>
+                <a:spcPts val="0"/>
+              </a:spcAft>
+            </a:pPr>
+            <a:r>
+              <a:rPr sz="1900" b="1">
+                <a:solidFill>
+                  <a:srgbClr val="FFFFFF"/>
+                </a:solidFill>
+                <a:latin typeface="Aptos"/>
+              </a:rPr>
+              <a:t>At what turn does my window fill?</a:t>
+            </a:r>
+          </a:p>
+        </p:txBody>
+      </p:sp>
+      <p:sp>
+        <p:nvSpPr>
+          <p:cNvPr id="19" name="TextBox 18"/>
+          <p:cNvSpPr txBox="1"/>
+          <p:nvPr/>
+        </p:nvSpPr>
+        <p:spPr>
+          <a:xfrm>
+            <a:off x="1554480" y="4434840"/>
+            <a:ext cx="6217920" cy="502920"/>
+          </a:xfrm>
+          <a:prstGeom prst="rect">
+            <a:avLst/>
+          </a:prstGeom>
+          <a:noFill/>
+        </p:spPr>
+        <p:txBody>
+          <a:bodyPr wrap="square" lIns="0" rIns="0" tIns="0" bIns="0" anchor="t">
+            <a:spAutoFit/>
+          </a:bodyPr>
+          <a:lstStyle/>
+          <a:p>
+            <a:pPr algn="l">
+              <a:lnSpc>
+                <a:spcPct val="110000"/>
+              </a:lnSpc>
+              <a:spcAft>
+                <a:spcPts val="0"/>
+              </a:spcAft>
+            </a:pPr>
+            <a:r>
+              <a:rPr sz="1400" b="0">
+                <a:solidFill>
+                  <a:srgbClr val="D7D5CE"/>
+                </a:solidFill>
+                <a:latin typeface="Aptos"/>
+              </a:rPr>
+              <a:t>Tokens per call plus growth per turn, against the window. Caching will not move it.</a:t>
+            </a:r>
+          </a:p>
+        </p:txBody>
+      </p:sp>
+      <p:sp>
+        <p:nvSpPr>
+          <p:cNvPr id="20" name="Rounded Rectangle 19"/>
+          <p:cNvSpPr/>
+          <p:nvPr/>
+        </p:nvSpPr>
+        <p:spPr>
+          <a:xfrm>
+            <a:off x="685800" y="5029200"/>
+            <a:ext cx="7223760" cy="1024128"/>
+          </a:xfrm>
+          <a:prstGeom prst="roundRect">
+            <a:avLst>
+              <a:gd name="adj" fmla="val 7000"/>
+            </a:avLst>
+          </a:prstGeom>
+          <a:solidFill>
+            <a:srgbClr val="1F1F1D"/>
+          </a:solidFill>
+          <a:ln>
+            <a:noFill/>
+          </a:ln>
+          <a:effectLst/>
+        </p:spPr>
+        <p:style>
+          <a:lnRef idx="1">
+            <a:schemeClr val="accent1"/>
+          </a:lnRef>
+          <a:fillRef idx="3">
+            <a:schemeClr val="accent1"/>
+          </a:fillRef>
+          <a:effectRef idx="2">
+            <a:schemeClr val="accent1"/>
+          </a:effectRef>
+          <a:fontRef idx="minor">
+            <a:schemeClr val="lt1"/>
+          </a:fontRef>
+        </p:style>
+        <p:txBody>
+          <a:bodyPr rtlCol="0" anchor="ctr"/>
+          <a:lstStyle/>
+          <a:p>
+            <a:pPr algn="ctr"/>
+          </a:p>
+        </p:txBody>
+      </p:sp>
+      <p:sp>
+        <p:nvSpPr>
+          <p:cNvPr id="21" name="TextBox 20"/>
+          <p:cNvSpPr txBox="1"/>
+          <p:nvPr/>
+        </p:nvSpPr>
+        <p:spPr>
+          <a:xfrm>
+            <a:off x="960120" y="5193792"/>
+            <a:ext cx="548640" cy="640080"/>
+          </a:xfrm>
+          <a:prstGeom prst="rect">
+            <a:avLst/>
+          </a:prstGeom>
+          <a:noFill/>
+        </p:spPr>
+        <p:txBody>
+          <a:bodyPr wrap="square" lIns="0" rIns="0" tIns="0" bIns="0" anchor="t">
+            <a:spAutoFit/>
+          </a:bodyPr>
+          <a:lstStyle/>
+          <a:p>
+            <a:pPr algn="l">
+              <a:lnSpc>
+                <a:spcPct val="108000"/>
+              </a:lnSpc>
+              <a:spcAft>
+                <a:spcPts val="0"/>
+              </a:spcAft>
+            </a:pPr>
+            <a:r>
+              <a:rPr sz="3400" b="1">
+                <a:solidFill>
+                  <a:srgbClr val="5AA3F0"/>
+                </a:solidFill>
+                <a:latin typeface="Aptos Display"/>
+              </a:rPr>
+              <a:t>4</a:t>
+            </a:r>
+          </a:p>
+        </p:txBody>
+      </p:sp>
+      <p:sp>
+        <p:nvSpPr>
+          <p:cNvPr id="22" name="TextBox 21"/>
+          <p:cNvSpPr txBox="1"/>
+          <p:nvPr/>
+        </p:nvSpPr>
+        <p:spPr>
+          <a:xfrm>
+            <a:off x="1554480" y="5157216"/>
+            <a:ext cx="6217920" cy="365760"/>
+          </a:xfrm>
+          <a:prstGeom prst="rect">
+            <a:avLst/>
+          </a:prstGeom>
+          <a:noFill/>
+        </p:spPr>
+        <p:txBody>
+          <a:bodyPr wrap="square" lIns="0" rIns="0" tIns="0" bIns="0" anchor="t">
+            <a:spAutoFit/>
+          </a:bodyPr>
+          <a:lstStyle/>
+          <a:p>
+            <a:pPr algn="l">
+              <a:lnSpc>
+                <a:spcPct val="108000"/>
+              </a:lnSpc>
+              <a:spcAft>
+                <a:spcPts val="0"/>
+              </a:spcAft>
+            </a:pPr>
+            <a:r>
+              <a:rPr sz="1900" b="1">
+                <a:solidFill>
+                  <a:srgbClr val="FFFFFF"/>
+                </a:solidFill>
+                <a:latin typeface="Aptos"/>
+              </a:rPr>
+              <a:t>Which item is the biggest share of my bill?</a:t>
+            </a:r>
+          </a:p>
+        </p:txBody>
+      </p:sp>
+      <p:sp>
+        <p:nvSpPr>
+          <p:cNvPr id="23" name="TextBox 22"/>
+          <p:cNvSpPr txBox="1"/>
+          <p:nvPr/>
+        </p:nvSpPr>
+        <p:spPr>
+          <a:xfrm>
+            <a:off x="1554480" y="5532120"/>
+            <a:ext cx="6217920" cy="502920"/>
+          </a:xfrm>
+          <a:prstGeom prst="rect">
+            <a:avLst/>
+          </a:prstGeom>
+          <a:noFill/>
+        </p:spPr>
+        <p:txBody>
+          <a:bodyPr wrap="square" lIns="0" rIns="0" tIns="0" bIns="0" anchor="t">
+            <a:spAutoFit/>
+          </a:bodyPr>
+          <a:lstStyle/>
+          <a:p>
+            <a:pPr algn="l">
+              <a:lnSpc>
+                <a:spcPct val="110000"/>
+              </a:lnSpc>
+              <a:spcAft>
+                <a:spcPts val="0"/>
+              </a:spcAft>
+            </a:pPr>
+            <a:r>
+              <a:rPr sz="1400" b="0">
+                <a:solidFill>
+                  <a:srgbClr val="D7D5CE"/>
+                </a:solidFill>
+                <a:latin typeface="Aptos"/>
+              </a:rPr>
+              <a:t>Run bill_report.py on a log. Then pick the lever: size, sends, or price.</a:t>
+            </a:r>
+          </a:p>
+        </p:txBody>
+      </p:sp>
+      <p:sp>
+        <p:nvSpPr>
+          <p:cNvPr id="24" name="TextBox 23"/>
+          <p:cNvSpPr txBox="1"/>
+          <p:nvPr/>
+        </p:nvSpPr>
+        <p:spPr>
+          <a:xfrm>
+            <a:off x="8321040" y="1783080"/>
+            <a:ext cx="3200400" cy="1737360"/>
+          </a:xfrm>
+          <a:prstGeom prst="rect">
+            <a:avLst/>
+          </a:prstGeom>
+          <a:noFill/>
+        </p:spPr>
+        <p:txBody>
+          <a:bodyPr wrap="square" lIns="0" rIns="0" tIns="0" bIns="0" anchor="t">
+            <a:spAutoFit/>
+          </a:bodyPr>
+          <a:lstStyle/>
+          <a:p>
+            <a:pPr algn="r">
+              <a:lnSpc>
+                <a:spcPct val="108000"/>
+              </a:lnSpc>
+              <a:spcAft>
+                <a:spcPts val="0"/>
+              </a:spcAft>
+            </a:pPr>
+            <a:r>
+              <a:rPr sz="3200" b="1">
+                <a:solidFill>
+                  <a:srgbClr val="FFFFFF"/>
+                </a:solidFill>
+                <a:latin typeface="Aptos Display"/>
+              </a:rPr>
+              <a:t>Thank you</a:t>
+            </a:r>
+          </a:p>
+          <a:p>
+            <a:pPr algn="r">
+              <a:lnSpc>
+                <a:spcPct val="108000"/>
+              </a:lnSpc>
+              <a:spcAft>
+                <a:spcPts val="0"/>
+              </a:spcAft>
+            </a:pPr>
+            <a:r>
+              <a:rPr sz="1700" b="1">
+                <a:solidFill>
+                  <a:srgbClr val="FFFFFF"/>
+                </a:solidFill>
+                <a:latin typeface="Aptos"/>
+              </a:rPr>
+              <a:t>Shyamji Tiwari</a:t>
+            </a:r>
+          </a:p>
+          <a:p>
+            <a:pPr algn="r">
+              <a:lnSpc>
+                <a:spcPct val="108000"/>
+              </a:lnSpc>
+              <a:spcAft>
+                <a:spcPts val="0"/>
+              </a:spcAft>
+            </a:pPr>
+            <a:r>
+              <a:rPr sz="1400" b="0">
+                <a:solidFill>
+                  <a:srgbClr val="D7D5CE"/>
+                </a:solidFill>
+                <a:latin typeface="Aptos"/>
+              </a:rPr>
+              <a:t>Applied Scientist, Amazon</a:t>
+            </a:r>
+          </a:p>
+          <a:p>
+            <a:pPr algn="r">
+              <a:lnSpc>
+                <a:spcPct val="108000"/>
+              </a:lnSpc>
+              <a:spcAft>
+                <a:spcPts val="0"/>
+              </a:spcAft>
+            </a:pPr>
+            <a:r>
+              <a:rPr sz="1200" b="0">
+                <a:solidFill>
+                  <a:srgbClr val="5AA3F0"/>
+                </a:solidFill>
+                <a:latin typeface="Aptos"/>
+              </a:rPr>
+              <a:t>github.com/ieee-ai/agentic-ai-26</a:t>
+            </a:r>
+          </a:p>
+          <a:p>
+            <a:pPr algn="r">
+              <a:lnSpc>
+                <a:spcPct val="108000"/>
+              </a:lnSpc>
+              <a:spcAft>
+                <a:spcPts val="0"/>
+              </a:spcAft>
+            </a:pPr>
+            <a:r>
+              <a:rPr sz="1200" b="0">
+                <a:solidFill>
+                  <a:srgbClr val="5AA3F0"/>
+                </a:solidFill>
+                <a:latin typeface="Aptos"/>
+              </a:rPr>
+              <a:t>/Saving-the-Tokens</a:t>
+            </a:r>
+          </a:p>
+        </p:txBody>
+      </p:sp>
+      <p:pic>
+        <p:nvPicPr>
+          <p:cNvPr id="25" name="Picture 24" descr="qr_dark.png"/>
+          <p:cNvPicPr>
+            <a:picLocks noChangeAspect="1"/>
+          </p:cNvPicPr>
+          <p:nvPr/>
+        </p:nvPicPr>
+        <p:blipFill>
+          <a:blip r:embed="rId2"/>
+          <a:stretch>
+            <a:fillRect/>
+          </a:stretch>
+        </p:blipFill>
+        <p:spPr>
+          <a:xfrm>
+            <a:off x="9921240" y="4023360"/>
+            <a:ext cx="1600200" cy="1600200"/>
+          </a:xfrm>
+          <a:prstGeom prst="rect">
+            <a:avLst/>
+          </a:prstGeom>
+        </p:spPr>
+      </p:pic>
+      <p:sp>
+        <p:nvSpPr>
+          <p:cNvPr id="26" name="TextBox 25"/>
+          <p:cNvSpPr txBox="1"/>
+          <p:nvPr/>
+        </p:nvSpPr>
+        <p:spPr>
+          <a:xfrm>
+            <a:off x="8321040" y="5715000"/>
+            <a:ext cx="3200400" cy="274320"/>
+          </a:xfrm>
+          <a:prstGeom prst="rect">
+            <a:avLst/>
+          </a:prstGeom>
+          <a:noFill/>
+        </p:spPr>
+        <p:txBody>
+          <a:bodyPr wrap="square" lIns="0" rIns="0" tIns="0" bIns="0" anchor="t">
+            <a:spAutoFit/>
+          </a:bodyPr>
+          <a:lstStyle/>
+          <a:p>
+            <a:pPr algn="r">
+              <a:lnSpc>
+                <a:spcPct val="108000"/>
+              </a:lnSpc>
+              <a:spcAft>
+                <a:spcPts val="0"/>
+              </a:spcAft>
+            </a:pPr>
+            <a:r>
+              <a:rPr sz="1200" b="0">
+                <a:solidFill>
+                  <a:srgbClr val="B5B2AA"/>
+                </a:solidFill>
+                <a:latin typeface="Aptos"/>
+              </a:rPr>
+              <a:t>slides, notebook, scripts</a:t>
+            </a:r>
+          </a:p>
+        </p:txBody>
+      </p:sp>
+      <p:sp>
+        <p:nvSpPr>
+          <p:cNvPr id="27" name="TextBox 26"/>
+          <p:cNvSpPr txBox="1"/>
+          <p:nvPr/>
+        </p:nvSpPr>
+        <p:spPr>
+          <a:xfrm>
+            <a:off x="685800" y="6473952"/>
+            <a:ext cx="5486400" cy="274320"/>
+          </a:xfrm>
+          <a:prstGeom prst="rect">
+            <a:avLst/>
+          </a:prstGeom>
+          <a:noFill/>
+        </p:spPr>
+        <p:txBody>
+          <a:bodyPr wrap="square" lIns="0" rIns="0" tIns="0" bIns="0" anchor="t">
+            <a:spAutoFit/>
+          </a:bodyPr>
+          <a:lstStyle/>
+          <a:p>
+            <a:pPr algn="l">
+              <a:lnSpc>
+                <a:spcPct val="108000"/>
+              </a:lnSpc>
+              <a:spcAft>
+                <a:spcPts val="0"/>
+              </a:spcAft>
+            </a:pPr>
+            <a:r>
+              <a:rPr sz="1100" b="0">
+                <a:solidFill>
+                  <a:srgbClr val="B5B2AA"/>
                 </a:solidFill>
                 <a:latin typeface="Aptos"/>
               </a:rPr>

</xml_diff>